<commit_message>
allowed selecting energy level on launchpad, changed playlists accordingly
</commit_message>
<xml_diff>
--- a/Design Log/Music Library.pptx
+++ b/Design Log/Music Library.pptx
@@ -5,7 +5,7 @@
     <p:sldMasterId id="2147483648" r:id="rId1"/>
   </p:sldMasterIdLst>
   <p:notesMasterIdLst>
-    <p:notesMasterId r:id="rId15"/>
+    <p:notesMasterId r:id="rId16"/>
   </p:notesMasterIdLst>
   <p:sldIdLst>
     <p:sldId id="256" r:id="rId2"/>
@@ -21,6 +21,7 @@
     <p:sldId id="267" r:id="rId12"/>
     <p:sldId id="268" r:id="rId13"/>
     <p:sldId id="269" r:id="rId14"/>
+    <p:sldId id="270" r:id="rId15"/>
   </p:sldIdLst>
   <p:sldSz cx="12192000" cy="6858000"/>
   <p:notesSz cx="6858000" cy="9144000"/>
@@ -209,7 +210,7 @@
           <a:p>
             <a:fld id="{69EAFAAE-CE2E-4AA9-83BD-55884CEF3EFD}" type="datetimeFigureOut">
               <a:rPr lang="nl-NL" smtClean="0"/>
-              <a:t>29-5-2025</a:t>
+              <a:t>4-6-2025</a:t>
             </a:fld>
             <a:endParaRPr lang="nl-NL"/>
           </a:p>
@@ -626,7 +627,7 @@
           <a:p>
             <a:fld id="{0506D139-8255-4032-8342-CDBE6BDAFC36}" type="datetimeFigureOut">
               <a:rPr lang="nl-NL" smtClean="0"/>
-              <a:t>29-5-2025</a:t>
+              <a:t>4-6-2025</a:t>
             </a:fld>
             <a:endParaRPr lang="nl-NL"/>
           </a:p>
@@ -826,7 +827,7 @@
           <a:p>
             <a:fld id="{0506D139-8255-4032-8342-CDBE6BDAFC36}" type="datetimeFigureOut">
               <a:rPr lang="nl-NL" smtClean="0"/>
-              <a:t>29-5-2025</a:t>
+              <a:t>4-6-2025</a:t>
             </a:fld>
             <a:endParaRPr lang="nl-NL"/>
           </a:p>
@@ -1036,7 +1037,7 @@
           <a:p>
             <a:fld id="{0506D139-8255-4032-8342-CDBE6BDAFC36}" type="datetimeFigureOut">
               <a:rPr lang="nl-NL" smtClean="0"/>
-              <a:t>29-5-2025</a:t>
+              <a:t>4-6-2025</a:t>
             </a:fld>
             <a:endParaRPr lang="nl-NL"/>
           </a:p>
@@ -1236,7 +1237,7 @@
           <a:p>
             <a:fld id="{0506D139-8255-4032-8342-CDBE6BDAFC36}" type="datetimeFigureOut">
               <a:rPr lang="nl-NL" smtClean="0"/>
-              <a:t>29-5-2025</a:t>
+              <a:t>4-6-2025</a:t>
             </a:fld>
             <a:endParaRPr lang="nl-NL"/>
           </a:p>
@@ -1512,7 +1513,7 @@
           <a:p>
             <a:fld id="{0506D139-8255-4032-8342-CDBE6BDAFC36}" type="datetimeFigureOut">
               <a:rPr lang="nl-NL" smtClean="0"/>
-              <a:t>29-5-2025</a:t>
+              <a:t>4-6-2025</a:t>
             </a:fld>
             <a:endParaRPr lang="nl-NL"/>
           </a:p>
@@ -1780,7 +1781,7 @@
           <a:p>
             <a:fld id="{0506D139-8255-4032-8342-CDBE6BDAFC36}" type="datetimeFigureOut">
               <a:rPr lang="nl-NL" smtClean="0"/>
-              <a:t>29-5-2025</a:t>
+              <a:t>4-6-2025</a:t>
             </a:fld>
             <a:endParaRPr lang="nl-NL"/>
           </a:p>
@@ -2195,7 +2196,7 @@
           <a:p>
             <a:fld id="{0506D139-8255-4032-8342-CDBE6BDAFC36}" type="datetimeFigureOut">
               <a:rPr lang="nl-NL" smtClean="0"/>
-              <a:t>29-5-2025</a:t>
+              <a:t>4-6-2025</a:t>
             </a:fld>
             <a:endParaRPr lang="nl-NL"/>
           </a:p>
@@ -2337,7 +2338,7 @@
           <a:p>
             <a:fld id="{0506D139-8255-4032-8342-CDBE6BDAFC36}" type="datetimeFigureOut">
               <a:rPr lang="nl-NL" smtClean="0"/>
-              <a:t>29-5-2025</a:t>
+              <a:t>4-6-2025</a:t>
             </a:fld>
             <a:endParaRPr lang="nl-NL"/>
           </a:p>
@@ -2450,7 +2451,7 @@
           <a:p>
             <a:fld id="{0506D139-8255-4032-8342-CDBE6BDAFC36}" type="datetimeFigureOut">
               <a:rPr lang="nl-NL" smtClean="0"/>
-              <a:t>29-5-2025</a:t>
+              <a:t>4-6-2025</a:t>
             </a:fld>
             <a:endParaRPr lang="nl-NL"/>
           </a:p>
@@ -2763,7 +2764,7 @@
           <a:p>
             <a:fld id="{0506D139-8255-4032-8342-CDBE6BDAFC36}" type="datetimeFigureOut">
               <a:rPr lang="nl-NL" smtClean="0"/>
-              <a:t>29-5-2025</a:t>
+              <a:t>4-6-2025</a:t>
             </a:fld>
             <a:endParaRPr lang="nl-NL"/>
           </a:p>
@@ -3052,7 +3053,7 @@
           <a:p>
             <a:fld id="{0506D139-8255-4032-8342-CDBE6BDAFC36}" type="datetimeFigureOut">
               <a:rPr lang="nl-NL" smtClean="0"/>
-              <a:t>29-5-2025</a:t>
+              <a:t>4-6-2025</a:t>
             </a:fld>
             <a:endParaRPr lang="nl-NL"/>
           </a:p>
@@ -3295,7 +3296,7 @@
           <a:p>
             <a:fld id="{0506D139-8255-4032-8342-CDBE6BDAFC36}" type="datetimeFigureOut">
               <a:rPr lang="nl-NL" smtClean="0"/>
-              <a:t>29-5-2025</a:t>
+              <a:t>4-6-2025</a:t>
             </a:fld>
             <a:endParaRPr lang="nl-NL"/>
           </a:p>
@@ -4671,6 +4672,447 @@
     <p:extLst>
       <p:ext uri="{BB962C8B-B14F-4D97-AF65-F5344CB8AC3E}">
         <p14:creationId xmlns:p14="http://schemas.microsoft.com/office/powerpoint/2010/main" val="20252145"/>
+      </p:ext>
+    </p:extLst>
+  </p:cSld>
+  <p:clrMapOvr>
+    <a:masterClrMapping/>
+  </p:clrMapOvr>
+</p:sld>
+</file>
+
+<file path=ppt/slides/slide14.xml><?xml version="1.0" encoding="utf-8"?>
+<p:sld xmlns:a="http://schemas.openxmlformats.org/drawingml/2006/main" xmlns:r="http://schemas.openxmlformats.org/officeDocument/2006/relationships" xmlns:p="http://schemas.openxmlformats.org/presentationml/2006/main">
+  <p:cSld>
+    <p:spTree>
+      <p:nvGrpSpPr>
+        <p:cNvPr id="1" name=""/>
+        <p:cNvGrpSpPr/>
+        <p:nvPr/>
+      </p:nvGrpSpPr>
+      <p:grpSpPr>
+        <a:xfrm>
+          <a:off x="0" y="0"/>
+          <a:ext cx="0" cy="0"/>
+          <a:chOff x="0" y="0"/>
+          <a:chExt cx="0" cy="0"/>
+        </a:xfrm>
+      </p:grpSpPr>
+      <p:sp>
+        <p:nvSpPr>
+          <p:cNvPr id="2" name="Title 1">
+            <a:extLst>
+              <a:ext uri="{FF2B5EF4-FFF2-40B4-BE49-F238E27FC236}">
+                <a16:creationId xmlns:a16="http://schemas.microsoft.com/office/drawing/2014/main" id="{2DF63892-FA3D-8752-77E5-F33D42F5D674}"/>
+              </a:ext>
+            </a:extLst>
+          </p:cNvPr>
+          <p:cNvSpPr>
+            <a:spLocks noGrp="1"/>
+          </p:cNvSpPr>
+          <p:nvPr>
+            <p:ph type="title"/>
+          </p:nvPr>
+        </p:nvSpPr>
+        <p:spPr/>
+        <p:txBody>
+          <a:bodyPr/>
+          <a:lstStyle/>
+          <a:p>
+            <a:r>
+              <a:rPr lang="nl-NL" dirty="0"/>
+              <a:t>Meta data	</a:t>
+            </a:r>
+          </a:p>
+        </p:txBody>
+      </p:sp>
+      <p:sp>
+        <p:nvSpPr>
+          <p:cNvPr id="3" name="Content Placeholder 2">
+            <a:extLst>
+              <a:ext uri="{FF2B5EF4-FFF2-40B4-BE49-F238E27FC236}">
+                <a16:creationId xmlns:a16="http://schemas.microsoft.com/office/drawing/2014/main" id="{47F533B6-D336-6BDB-14B8-E3AE32FA5430}"/>
+              </a:ext>
+            </a:extLst>
+          </p:cNvPr>
+          <p:cNvSpPr>
+            <a:spLocks noGrp="1"/>
+          </p:cNvSpPr>
+          <p:nvPr>
+            <p:ph idx="1"/>
+          </p:nvPr>
+        </p:nvSpPr>
+        <p:spPr/>
+        <p:txBody>
+          <a:bodyPr/>
+          <a:lstStyle/>
+          <a:p>
+            <a:r>
+              <a:rPr lang="nl-NL" dirty="0" err="1"/>
+              <a:t>Traktor</a:t>
+            </a:r>
+            <a:r>
+              <a:rPr lang="nl-NL" dirty="0"/>
+              <a:t> stores </a:t>
+            </a:r>
+            <a:r>
+              <a:rPr lang="nl-NL" dirty="0" err="1"/>
+              <a:t>the</a:t>
+            </a:r>
+            <a:r>
+              <a:rPr lang="nl-NL" dirty="0"/>
+              <a:t> ID3 tag information in </a:t>
+            </a:r>
+            <a:r>
+              <a:rPr lang="nl-NL" dirty="0" err="1"/>
+              <a:t>its</a:t>
+            </a:r>
+            <a:r>
+              <a:rPr lang="nl-NL" dirty="0"/>
+              <a:t> </a:t>
+            </a:r>
+            <a:r>
+              <a:rPr lang="nl-NL" dirty="0" err="1"/>
+              <a:t>collection</a:t>
+            </a:r>
+            <a:r>
+              <a:rPr lang="nl-NL" dirty="0"/>
+              <a:t> </a:t>
+            </a:r>
+            <a:r>
+              <a:rPr lang="nl-NL"/>
+              <a:t>xml</a:t>
+            </a:r>
+          </a:p>
+          <a:p>
+            <a:r>
+              <a:rPr lang="nl-NL" dirty="0"/>
+              <a:t>Meta data </a:t>
+            </a:r>
+            <a:r>
+              <a:rPr lang="nl-NL" dirty="0" err="1"/>
+              <a:t>from</a:t>
+            </a:r>
+            <a:r>
+              <a:rPr lang="nl-NL" dirty="0"/>
+              <a:t> ID3 tags </a:t>
+            </a:r>
+            <a:r>
+              <a:rPr lang="nl-NL" dirty="0" err="1"/>
+              <a:t>cannot</a:t>
+            </a:r>
+            <a:r>
+              <a:rPr lang="nl-NL" dirty="0"/>
+              <a:t> </a:t>
+            </a:r>
+            <a:r>
+              <a:rPr lang="nl-NL" dirty="0" err="1"/>
+              <a:t>be</a:t>
+            </a:r>
+            <a:r>
+              <a:rPr lang="nl-NL" dirty="0"/>
+              <a:t> </a:t>
+            </a:r>
+            <a:r>
+              <a:rPr lang="nl-NL" dirty="0" err="1"/>
+              <a:t>read</a:t>
+            </a:r>
+            <a:r>
+              <a:rPr lang="nl-NL" dirty="0"/>
+              <a:t> </a:t>
+            </a:r>
+            <a:r>
+              <a:rPr lang="nl-NL" dirty="0" err="1"/>
+              <a:t>by</a:t>
+            </a:r>
+            <a:r>
+              <a:rPr lang="nl-NL" dirty="0"/>
+              <a:t> supercollider, </a:t>
+            </a:r>
+            <a:r>
+              <a:rPr lang="nl-NL" dirty="0" err="1"/>
+              <a:t>so</a:t>
+            </a:r>
+            <a:r>
+              <a:rPr lang="nl-NL" dirty="0"/>
+              <a:t> we </a:t>
+            </a:r>
+            <a:r>
+              <a:rPr lang="nl-NL" dirty="0" err="1"/>
+              <a:t>need</a:t>
+            </a:r>
+            <a:r>
+              <a:rPr lang="nl-NL" dirty="0"/>
+              <a:t> </a:t>
+            </a:r>
+            <a:r>
+              <a:rPr lang="nl-NL" dirty="0" err="1"/>
+              <a:t>to</a:t>
+            </a:r>
+            <a:r>
+              <a:rPr lang="nl-NL" dirty="0"/>
+              <a:t> </a:t>
+            </a:r>
+            <a:r>
+              <a:rPr lang="nl-NL" dirty="0" err="1"/>
+              <a:t>involve</a:t>
+            </a:r>
+            <a:r>
+              <a:rPr lang="nl-NL" dirty="0"/>
+              <a:t> a </a:t>
+            </a:r>
+            <a:r>
+              <a:rPr lang="nl-NL" dirty="0" err="1"/>
+              <a:t>third</a:t>
+            </a:r>
+            <a:r>
+              <a:rPr lang="nl-NL" dirty="0"/>
+              <a:t> party tool, </a:t>
+            </a:r>
+            <a:r>
+              <a:rPr lang="nl-NL" dirty="0" err="1"/>
+              <a:t>using</a:t>
+            </a:r>
+            <a:r>
+              <a:rPr lang="nl-NL" dirty="0"/>
+              <a:t> </a:t>
+            </a:r>
+            <a:r>
+              <a:rPr lang="nl-NL" dirty="0" err="1"/>
+              <a:t>UnixCmd</a:t>
+            </a:r>
+            <a:endParaRPr lang="nl-NL" dirty="0"/>
+          </a:p>
+          <a:p>
+            <a:pPr lvl="1"/>
+            <a:r>
+              <a:rPr lang="nl-NL" dirty="0"/>
+              <a:t>https://id3.org/id3v2.4.0-frames</a:t>
+            </a:r>
+          </a:p>
+          <a:p>
+            <a:pPr lvl="1"/>
+            <a:r>
+              <a:rPr lang="nl-NL" dirty="0" err="1"/>
+              <a:t>Ffprobe</a:t>
+            </a:r>
+            <a:r>
+              <a:rPr lang="nl-NL" dirty="0"/>
+              <a:t> </a:t>
+            </a:r>
+            <a:r>
+              <a:rPr lang="nl-NL" dirty="0" err="1"/>
+              <a:t>works</a:t>
+            </a:r>
+            <a:r>
+              <a:rPr lang="nl-NL" dirty="0"/>
+              <a:t> (</a:t>
+            </a:r>
+            <a:r>
+              <a:rPr lang="nl-NL" dirty="0" err="1"/>
+              <a:t>see</a:t>
+            </a:r>
+            <a:r>
+              <a:rPr lang="nl-NL" dirty="0"/>
+              <a:t> </a:t>
+            </a:r>
+            <a:r>
+              <a:rPr lang="nl-NL" dirty="0" err="1"/>
+              <a:t>TrackDiscription</a:t>
+            </a:r>
+            <a:r>
+              <a:rPr lang="nl-NL" dirty="0"/>
+              <a:t>. </a:t>
+            </a:r>
+            <a:r>
+              <a:rPr lang="nl-NL" dirty="0" err="1"/>
+              <a:t>energyFromMetaData</a:t>
+            </a:r>
+            <a:r>
+              <a:rPr lang="nl-NL" dirty="0"/>
+              <a:t>)</a:t>
+            </a:r>
+          </a:p>
+          <a:p>
+            <a:pPr lvl="2"/>
+            <a:r>
+              <a:rPr lang="nl-NL" dirty="0"/>
+              <a:t>It is slow </a:t>
+            </a:r>
+            <a:r>
+              <a:rPr lang="nl-NL" dirty="0" err="1"/>
+              <a:t>because</a:t>
+            </a:r>
+            <a:r>
+              <a:rPr lang="nl-NL" dirty="0"/>
+              <a:t> </a:t>
+            </a:r>
+            <a:r>
+              <a:rPr lang="nl-NL" dirty="0" err="1"/>
+              <a:t>it</a:t>
+            </a:r>
+            <a:r>
+              <a:rPr lang="nl-NL" dirty="0"/>
+              <a:t> </a:t>
+            </a:r>
+            <a:r>
+              <a:rPr lang="nl-NL" dirty="0" err="1"/>
+              <a:t>needs</a:t>
+            </a:r>
+            <a:r>
+              <a:rPr lang="nl-NL" dirty="0"/>
+              <a:t> </a:t>
+            </a:r>
+            <a:r>
+              <a:rPr lang="nl-NL" dirty="0" err="1"/>
+              <a:t>to</a:t>
+            </a:r>
+            <a:r>
+              <a:rPr lang="nl-NL" dirty="0"/>
+              <a:t> </a:t>
+            </a:r>
+            <a:r>
+              <a:rPr lang="nl-NL" dirty="0" err="1"/>
+              <a:t>fully</a:t>
+            </a:r>
+            <a:r>
+              <a:rPr lang="nl-NL" dirty="0"/>
+              <a:t> load </a:t>
+            </a:r>
+            <a:r>
+              <a:rPr lang="nl-NL" dirty="0" err="1"/>
+              <a:t>each</a:t>
+            </a:r>
+            <a:r>
+              <a:rPr lang="nl-NL" dirty="0"/>
+              <a:t> track</a:t>
+            </a:r>
+          </a:p>
+          <a:p>
+            <a:pPr lvl="1"/>
+            <a:r>
+              <a:rPr lang="nl-NL" dirty="0"/>
+              <a:t>We </a:t>
+            </a:r>
+            <a:r>
+              <a:rPr lang="nl-NL" dirty="0" err="1"/>
+              <a:t>can</a:t>
+            </a:r>
+            <a:r>
+              <a:rPr lang="nl-NL" dirty="0"/>
+              <a:t> </a:t>
+            </a:r>
+            <a:r>
+              <a:rPr lang="nl-NL" dirty="0" err="1"/>
+              <a:t>use</a:t>
+            </a:r>
+            <a:r>
+              <a:rPr lang="nl-NL" dirty="0"/>
+              <a:t> a python tool </a:t>
+            </a:r>
+            <a:r>
+              <a:rPr lang="nl-NL" dirty="0" err="1"/>
+              <a:t>such</a:t>
+            </a:r>
+            <a:r>
+              <a:rPr lang="nl-NL" dirty="0"/>
+              <a:t> as https://mutagen.readthedocs.io/en/latest/user/id3.html , we </a:t>
+            </a:r>
+            <a:r>
+              <a:rPr lang="nl-NL" dirty="0" err="1"/>
+              <a:t>should</a:t>
+            </a:r>
+            <a:r>
+              <a:rPr lang="nl-NL" dirty="0"/>
+              <a:t> make a python script </a:t>
+            </a:r>
+            <a:r>
+              <a:rPr lang="nl-NL" dirty="0" err="1"/>
+              <a:t>which</a:t>
+            </a:r>
+            <a:r>
+              <a:rPr lang="nl-NL" dirty="0"/>
+              <a:t> </a:t>
+            </a:r>
+            <a:r>
+              <a:rPr lang="nl-NL" dirty="0" err="1"/>
+              <a:t>notes</a:t>
+            </a:r>
+            <a:r>
+              <a:rPr lang="nl-NL" dirty="0"/>
+              <a:t> </a:t>
+            </a:r>
+            <a:r>
+              <a:rPr lang="nl-NL" dirty="0" err="1"/>
+              <a:t>the</a:t>
+            </a:r>
+            <a:r>
+              <a:rPr lang="nl-NL" dirty="0"/>
+              <a:t> </a:t>
+            </a:r>
+            <a:r>
+              <a:rPr lang="nl-NL" dirty="0" err="1"/>
+              <a:t>desired</a:t>
+            </a:r>
+            <a:r>
+              <a:rPr lang="nl-NL" dirty="0"/>
+              <a:t> information in a YAML file </a:t>
+            </a:r>
+            <a:r>
+              <a:rPr lang="nl-NL" dirty="0" err="1"/>
+              <a:t>for</a:t>
+            </a:r>
+            <a:r>
+              <a:rPr lang="nl-NL" dirty="0"/>
+              <a:t> </a:t>
+            </a:r>
+            <a:r>
+              <a:rPr lang="nl-NL" dirty="0" err="1"/>
+              <a:t>each</a:t>
+            </a:r>
+            <a:r>
+              <a:rPr lang="nl-NL" dirty="0"/>
+              <a:t> track, </a:t>
+            </a:r>
+            <a:r>
+              <a:rPr lang="nl-NL" dirty="0" err="1"/>
+              <a:t>then</a:t>
+            </a:r>
+            <a:r>
+              <a:rPr lang="nl-NL" dirty="0"/>
+              <a:t> supercollider </a:t>
+            </a:r>
+            <a:r>
+              <a:rPr lang="nl-NL" dirty="0" err="1"/>
+              <a:t>can</a:t>
+            </a:r>
+            <a:r>
+              <a:rPr lang="nl-NL" dirty="0"/>
+              <a:t> </a:t>
+            </a:r>
+            <a:r>
+              <a:rPr lang="nl-NL" dirty="0" err="1"/>
+              <a:t>read</a:t>
+            </a:r>
+            <a:r>
+              <a:rPr lang="nl-NL" dirty="0"/>
+              <a:t> </a:t>
+            </a:r>
+            <a:r>
+              <a:rPr lang="nl-NL" dirty="0" err="1"/>
+              <a:t>this</a:t>
+            </a:r>
+            <a:r>
+              <a:rPr lang="nl-NL" dirty="0"/>
+              <a:t> YAML file</a:t>
+            </a:r>
+          </a:p>
+        </p:txBody>
+      </p:sp>
+    </p:spTree>
+    <p:extLst>
+      <p:ext uri="{BB962C8B-B14F-4D97-AF65-F5344CB8AC3E}">
+        <p14:creationId xmlns:p14="http://schemas.microsoft.com/office/powerpoint/2010/main" val="188665701"/>
       </p:ext>
     </p:extLst>
   </p:cSld>

</xml_diff>

<commit_message>
added riser support for thrustmaster, and changed gain staging
</commit_message>
<xml_diff>
--- a/Design Log/Music Library.pptx
+++ b/Design Log/Music Library.pptx
@@ -5,7 +5,7 @@
     <p:sldMasterId id="2147483648" r:id="rId1"/>
   </p:sldMasterIdLst>
   <p:notesMasterIdLst>
-    <p:notesMasterId r:id="rId16"/>
+    <p:notesMasterId r:id="rId17"/>
   </p:notesMasterIdLst>
   <p:sldIdLst>
     <p:sldId id="256" r:id="rId2"/>
@@ -22,6 +22,7 @@
     <p:sldId id="268" r:id="rId13"/>
     <p:sldId id="269" r:id="rId14"/>
     <p:sldId id="270" r:id="rId15"/>
+    <p:sldId id="271" r:id="rId16"/>
   </p:sldIdLst>
   <p:sldSz cx="12192000" cy="6858000"/>
   <p:notesSz cx="6858000" cy="9144000"/>
@@ -210,7 +211,7 @@
           <a:p>
             <a:fld id="{69EAFAAE-CE2E-4AA9-83BD-55884CEF3EFD}" type="datetimeFigureOut">
               <a:rPr lang="nl-NL" smtClean="0"/>
-              <a:t>12-6-2025</a:t>
+              <a:t>24-6-2025</a:t>
             </a:fld>
             <a:endParaRPr lang="nl-NL"/>
           </a:p>
@@ -627,7 +628,7 @@
           <a:p>
             <a:fld id="{0506D139-8255-4032-8342-CDBE6BDAFC36}" type="datetimeFigureOut">
               <a:rPr lang="nl-NL" smtClean="0"/>
-              <a:t>12-6-2025</a:t>
+              <a:t>24-6-2025</a:t>
             </a:fld>
             <a:endParaRPr lang="nl-NL"/>
           </a:p>
@@ -827,7 +828,7 @@
           <a:p>
             <a:fld id="{0506D139-8255-4032-8342-CDBE6BDAFC36}" type="datetimeFigureOut">
               <a:rPr lang="nl-NL" smtClean="0"/>
-              <a:t>12-6-2025</a:t>
+              <a:t>24-6-2025</a:t>
             </a:fld>
             <a:endParaRPr lang="nl-NL"/>
           </a:p>
@@ -1037,7 +1038,7 @@
           <a:p>
             <a:fld id="{0506D139-8255-4032-8342-CDBE6BDAFC36}" type="datetimeFigureOut">
               <a:rPr lang="nl-NL" smtClean="0"/>
-              <a:t>12-6-2025</a:t>
+              <a:t>24-6-2025</a:t>
             </a:fld>
             <a:endParaRPr lang="nl-NL"/>
           </a:p>
@@ -1237,7 +1238,7 @@
           <a:p>
             <a:fld id="{0506D139-8255-4032-8342-CDBE6BDAFC36}" type="datetimeFigureOut">
               <a:rPr lang="nl-NL" smtClean="0"/>
-              <a:t>12-6-2025</a:t>
+              <a:t>24-6-2025</a:t>
             </a:fld>
             <a:endParaRPr lang="nl-NL"/>
           </a:p>
@@ -1513,7 +1514,7 @@
           <a:p>
             <a:fld id="{0506D139-8255-4032-8342-CDBE6BDAFC36}" type="datetimeFigureOut">
               <a:rPr lang="nl-NL" smtClean="0"/>
-              <a:t>12-6-2025</a:t>
+              <a:t>24-6-2025</a:t>
             </a:fld>
             <a:endParaRPr lang="nl-NL"/>
           </a:p>
@@ -1781,7 +1782,7 @@
           <a:p>
             <a:fld id="{0506D139-8255-4032-8342-CDBE6BDAFC36}" type="datetimeFigureOut">
               <a:rPr lang="nl-NL" smtClean="0"/>
-              <a:t>12-6-2025</a:t>
+              <a:t>24-6-2025</a:t>
             </a:fld>
             <a:endParaRPr lang="nl-NL"/>
           </a:p>
@@ -2196,7 +2197,7 @@
           <a:p>
             <a:fld id="{0506D139-8255-4032-8342-CDBE6BDAFC36}" type="datetimeFigureOut">
               <a:rPr lang="nl-NL" smtClean="0"/>
-              <a:t>12-6-2025</a:t>
+              <a:t>24-6-2025</a:t>
             </a:fld>
             <a:endParaRPr lang="nl-NL"/>
           </a:p>
@@ -2338,7 +2339,7 @@
           <a:p>
             <a:fld id="{0506D139-8255-4032-8342-CDBE6BDAFC36}" type="datetimeFigureOut">
               <a:rPr lang="nl-NL" smtClean="0"/>
-              <a:t>12-6-2025</a:t>
+              <a:t>24-6-2025</a:t>
             </a:fld>
             <a:endParaRPr lang="nl-NL"/>
           </a:p>
@@ -2451,7 +2452,7 @@
           <a:p>
             <a:fld id="{0506D139-8255-4032-8342-CDBE6BDAFC36}" type="datetimeFigureOut">
               <a:rPr lang="nl-NL" smtClean="0"/>
-              <a:t>12-6-2025</a:t>
+              <a:t>24-6-2025</a:t>
             </a:fld>
             <a:endParaRPr lang="nl-NL"/>
           </a:p>
@@ -2764,7 +2765,7 @@
           <a:p>
             <a:fld id="{0506D139-8255-4032-8342-CDBE6BDAFC36}" type="datetimeFigureOut">
               <a:rPr lang="nl-NL" smtClean="0"/>
-              <a:t>12-6-2025</a:t>
+              <a:t>24-6-2025</a:t>
             </a:fld>
             <a:endParaRPr lang="nl-NL"/>
           </a:p>
@@ -3053,7 +3054,7 @@
           <a:p>
             <a:fld id="{0506D139-8255-4032-8342-CDBE6BDAFC36}" type="datetimeFigureOut">
               <a:rPr lang="nl-NL" smtClean="0"/>
-              <a:t>12-6-2025</a:t>
+              <a:t>24-6-2025</a:t>
             </a:fld>
             <a:endParaRPr lang="nl-NL"/>
           </a:p>
@@ -3296,7 +3297,7 @@
           <a:p>
             <a:fld id="{0506D139-8255-4032-8342-CDBE6BDAFC36}" type="datetimeFigureOut">
               <a:rPr lang="nl-NL" smtClean="0"/>
-              <a:t>12-6-2025</a:t>
+              <a:t>24-6-2025</a:t>
             </a:fld>
             <a:endParaRPr lang="nl-NL"/>
           </a:p>
@@ -5113,6 +5114,133 @@
     <p:extLst>
       <p:ext uri="{BB962C8B-B14F-4D97-AF65-F5344CB8AC3E}">
         <p14:creationId xmlns:p14="http://schemas.microsoft.com/office/powerpoint/2010/main" val="188665701"/>
+      </p:ext>
+    </p:extLst>
+  </p:cSld>
+  <p:clrMapOvr>
+    <a:masterClrMapping/>
+  </p:clrMapOvr>
+</p:sld>
+</file>
+
+<file path=ppt/slides/slide15.xml><?xml version="1.0" encoding="utf-8"?>
+<p:sld xmlns:a="http://schemas.openxmlformats.org/drawingml/2006/main" xmlns:r="http://schemas.openxmlformats.org/officeDocument/2006/relationships" xmlns:p="http://schemas.openxmlformats.org/presentationml/2006/main">
+  <p:cSld>
+    <p:spTree>
+      <p:nvGrpSpPr>
+        <p:cNvPr id="1" name=""/>
+        <p:cNvGrpSpPr/>
+        <p:nvPr/>
+      </p:nvGrpSpPr>
+      <p:grpSpPr>
+        <a:xfrm>
+          <a:off x="0" y="0"/>
+          <a:ext cx="0" cy="0"/>
+          <a:chOff x="0" y="0"/>
+          <a:chExt cx="0" cy="0"/>
+        </a:xfrm>
+      </p:grpSpPr>
+      <p:sp>
+        <p:nvSpPr>
+          <p:cNvPr id="2" name="Title 1">
+            <a:extLst>
+              <a:ext uri="{FF2B5EF4-FFF2-40B4-BE49-F238E27FC236}">
+                <a16:creationId xmlns:a16="http://schemas.microsoft.com/office/drawing/2014/main" id="{BB5A75F3-3684-F049-08DC-25BB2E46699C}"/>
+              </a:ext>
+            </a:extLst>
+          </p:cNvPr>
+          <p:cNvSpPr>
+            <a:spLocks noGrp="1"/>
+          </p:cNvSpPr>
+          <p:nvPr>
+            <p:ph type="title"/>
+          </p:nvPr>
+        </p:nvSpPr>
+        <p:spPr/>
+        <p:txBody>
+          <a:bodyPr/>
+          <a:lstStyle/>
+          <a:p>
+            <a:r>
+              <a:rPr lang="nl-NL" dirty="0"/>
+              <a:t>New Playlist, barcode </a:t>
+            </a:r>
+            <a:r>
+              <a:rPr lang="nl-NL" dirty="0" err="1"/>
+              <a:t>to</a:t>
+            </a:r>
+            <a:r>
+              <a:rPr lang="nl-NL" dirty="0"/>
+              <a:t> </a:t>
+            </a:r>
+            <a:r>
+              <a:rPr lang="nl-NL" dirty="0" err="1"/>
+              <a:t>be</a:t>
+            </a:r>
+            <a:r>
+              <a:rPr lang="nl-NL" dirty="0"/>
+              <a:t> </a:t>
+            </a:r>
+            <a:r>
+              <a:rPr lang="nl-NL" dirty="0" err="1"/>
+              <a:t>generated</a:t>
+            </a:r>
+            <a:endParaRPr lang="nl-NL" dirty="0"/>
+          </a:p>
+        </p:txBody>
+      </p:sp>
+      <p:sp>
+        <p:nvSpPr>
+          <p:cNvPr id="3" name="Content Placeholder 2">
+            <a:extLst>
+              <a:ext uri="{FF2B5EF4-FFF2-40B4-BE49-F238E27FC236}">
+                <a16:creationId xmlns:a16="http://schemas.microsoft.com/office/drawing/2014/main" id="{CBCD23D1-79EE-E2C3-2F7B-39014A13B4C3}"/>
+              </a:ext>
+            </a:extLst>
+          </p:cNvPr>
+          <p:cNvSpPr>
+            <a:spLocks noGrp="1"/>
+          </p:cNvSpPr>
+          <p:nvPr>
+            <p:ph idx="1"/>
+          </p:nvPr>
+        </p:nvSpPr>
+        <p:spPr/>
+        <p:txBody>
+          <a:bodyPr/>
+          <a:lstStyle/>
+          <a:p>
+            <a:r>
+              <a:rPr lang="nl-NL" dirty="0"/>
+              <a:t>Sorry I make </a:t>
+            </a:r>
+            <a:r>
+              <a:rPr lang="nl-NL" dirty="0" err="1"/>
+              <a:t>you</a:t>
+            </a:r>
+            <a:r>
+              <a:rPr lang="nl-NL" dirty="0"/>
+              <a:t> </a:t>
+            </a:r>
+            <a:r>
+              <a:rPr lang="nl-NL" dirty="0" err="1"/>
+              <a:t>lush</a:t>
+            </a:r>
+            <a:endParaRPr lang="nl-NL" dirty="0"/>
+          </a:p>
+          <a:p>
+            <a:r>
+              <a:rPr lang="nl-NL" dirty="0" err="1"/>
+              <a:t>History</a:t>
+            </a:r>
+            <a:endParaRPr lang="nl-NL" dirty="0"/>
+          </a:p>
+        </p:txBody>
+      </p:sp>
+    </p:spTree>
+    <p:extLst>
+      <p:ext uri="{BB962C8B-B14F-4D97-AF65-F5344CB8AC3E}">
+        <p14:creationId xmlns:p14="http://schemas.microsoft.com/office/powerpoint/2010/main" val="722126772"/>
       </p:ext>
     </p:extLst>
   </p:cSld>

</xml_diff>